<commit_message>
feat(speech): simplify and shorten oral presentation scripts for all 9 slides to clear A2-B1 English
</commit_message>
<xml_diff>
--- a/Social_Networks_in_My_Life.pptx
+++ b/Social_Networks_in_My_Life.pptx
@@ -113,6 +113,1130 @@
     </a:lvl9pPr>
   </p:defaultTextStyle>
 </p:presentation>
+</file>
+
+<file path=ppt/notesMasters/notesMaster1.xml><?xml version="1.0" encoding="utf-8"?>
+<p:notesMaster xmlns:a="http://schemas.openxmlformats.org/drawingml/2006/main" xmlns:p="http://schemas.openxmlformats.org/presentationml/2006/main" xmlns:r="http://schemas.openxmlformats.org/officeDocument/2006/relationships">
+  <p:cSld>
+    <p:bg>
+      <p:bgRef idx="1001">
+        <a:schemeClr val="bg1"/>
+      </p:bgRef>
+    </p:bg>
+    <p:spTree>
+      <p:nvGrpSpPr>
+        <p:cNvPr id="1" name=""/>
+        <p:cNvGrpSpPr/>
+        <p:nvPr/>
+      </p:nvGrpSpPr>
+      <p:grpSpPr>
+        <a:xfrm>
+          <a:off x="0" y="0"/>
+          <a:ext cx="0" cy="0"/>
+          <a:chOff x="0" y="0"/>
+          <a:chExt cx="0" cy="0"/>
+        </a:xfrm>
+      </p:grpSpPr>
+      <p:sp>
+        <p:nvSpPr>
+          <p:cNvPr id="2" name="Header Placeholder 1"/>
+          <p:cNvSpPr>
+            <a:spLocks noGrp="1"/>
+          </p:cNvSpPr>
+          <p:nvPr>
+            <p:ph type="hdr" sz="quarter"/>
+          </p:nvPr>
+        </p:nvSpPr>
+        <p:spPr>
+          <a:xfrm>
+            <a:off x="0" y="0"/>
+            <a:ext cx="2971800" cy="457200"/>
+          </a:xfrm>
+          <a:prstGeom prst="rect">
+            <a:avLst/>
+          </a:prstGeom>
+        </p:spPr>
+        <p:txBody>
+          <a:bodyPr vert="horz" lIns="91440" tIns="45720" rIns="91440" bIns="45720" rtlCol="0"/>
+          <a:lstStyle>
+            <a:lvl1pPr algn="l">
+              <a:defRPr sz="1200"/>
+            </a:lvl1pPr>
+          </a:lstStyle>
+          <a:p>
+            <a:endParaRPr lang="en-US"/>
+          </a:p>
+        </p:txBody>
+      </p:sp>
+      <p:sp>
+        <p:nvSpPr>
+          <p:cNvPr id="3" name="Date Placeholder 2"/>
+          <p:cNvSpPr>
+            <a:spLocks noGrp="1"/>
+          </p:cNvSpPr>
+          <p:nvPr>
+            <p:ph type="dt" idx="1"/>
+          </p:nvPr>
+        </p:nvSpPr>
+        <p:spPr>
+          <a:xfrm>
+            <a:off x="3884613" y="0"/>
+            <a:ext cx="2971800" cy="457200"/>
+          </a:xfrm>
+          <a:prstGeom prst="rect">
+            <a:avLst/>
+          </a:prstGeom>
+        </p:spPr>
+        <p:txBody>
+          <a:bodyPr vert="horz" lIns="91440" tIns="45720" rIns="91440" bIns="45720" rtlCol="0"/>
+          <a:lstStyle>
+            <a:lvl1pPr algn="r">
+              <a:defRPr sz="1200"/>
+            </a:lvl1pPr>
+          </a:lstStyle>
+          <a:p>
+            <a:fld id="{0F89C1C7-3DCD-1040-A9CF-14679D8B5DDD}" type="datetimeFigureOut">
+              <a:rPr lang="en-US" smtClean="0"/>
+              <a:t>10/17/16</a:t>
+            </a:fld>
+            <a:endParaRPr lang="en-US"/>
+          </a:p>
+        </p:txBody>
+      </p:sp>
+      <p:sp>
+        <p:nvSpPr>
+          <p:cNvPr id="4" name="Slide Image Placeholder 3"/>
+          <p:cNvSpPr>
+            <a:spLocks noGrp="1" noRot="1" noChangeAspect="1"/>
+          </p:cNvSpPr>
+          <p:nvPr>
+            <p:ph type="sldImg" idx="2"/>
+          </p:nvPr>
+        </p:nvSpPr>
+        <p:spPr>
+          <a:xfrm>
+            <a:off x="1143000" y="685800"/>
+            <a:ext cx="4572000" cy="3429000"/>
+          </a:xfrm>
+          <a:prstGeom prst="rect">
+            <a:avLst/>
+          </a:prstGeom>
+          <a:noFill/>
+          <a:ln w="12700">
+            <a:solidFill>
+              <a:prstClr val="black"/>
+            </a:solidFill>
+          </a:ln>
+        </p:spPr>
+        <p:txBody>
+          <a:bodyPr vert="horz" lIns="91440" tIns="45720" rIns="91440" bIns="45720" rtlCol="0" anchor="ctr"/>
+          <a:lstStyle/>
+          <a:p>
+            <a:endParaRPr lang="en-US"/>
+          </a:p>
+        </p:txBody>
+      </p:sp>
+      <p:sp>
+        <p:nvSpPr>
+          <p:cNvPr id="5" name="Notes Placeholder 4"/>
+          <p:cNvSpPr>
+            <a:spLocks noGrp="1"/>
+          </p:cNvSpPr>
+          <p:nvPr>
+            <p:ph type="body" sz="quarter" idx="3"/>
+          </p:nvPr>
+        </p:nvSpPr>
+        <p:spPr>
+          <a:xfrm>
+            <a:off x="685800" y="4343400"/>
+            <a:ext cx="5486400" cy="4114800"/>
+          </a:xfrm>
+          <a:prstGeom prst="rect">
+            <a:avLst/>
+          </a:prstGeom>
+        </p:spPr>
+        <p:txBody>
+          <a:bodyPr vert="horz" lIns="91440" tIns="45720" rIns="91440" bIns="45720" rtlCol="0"/>
+          <a:lstStyle/>
+          <a:p>
+            <a:pPr lvl="0"/>
+            <a:r>
+              <a:rPr lang="en-US" smtClean="0"/>
+              <a:t>Click to edit Master text styles</a:t>
+            </a:r>
+          </a:p>
+          <a:p>
+            <a:pPr lvl="1"/>
+            <a:r>
+              <a:rPr lang="en-US" smtClean="0"/>
+              <a:t>Second level</a:t>
+            </a:r>
+          </a:p>
+          <a:p>
+            <a:pPr lvl="2"/>
+            <a:r>
+              <a:rPr lang="en-US" smtClean="0"/>
+              <a:t>Third level</a:t>
+            </a:r>
+          </a:p>
+          <a:p>
+            <a:pPr lvl="3"/>
+            <a:r>
+              <a:rPr lang="en-US" smtClean="0"/>
+              <a:t>Fourth level</a:t>
+            </a:r>
+          </a:p>
+          <a:p>
+            <a:pPr lvl="4"/>
+            <a:r>
+              <a:rPr lang="en-US" smtClean="0"/>
+              <a:t>Fifth level</a:t>
+            </a:r>
+            <a:endParaRPr lang="en-US"/>
+          </a:p>
+        </p:txBody>
+      </p:sp>
+      <p:sp>
+        <p:nvSpPr>
+          <p:cNvPr id="6" name="Footer Placeholder 5"/>
+          <p:cNvSpPr>
+            <a:spLocks noGrp="1"/>
+          </p:cNvSpPr>
+          <p:nvPr>
+            <p:ph type="ftr" sz="quarter" idx="4"/>
+          </p:nvPr>
+        </p:nvSpPr>
+        <p:spPr>
+          <a:xfrm>
+            <a:off x="0" y="8685213"/>
+            <a:ext cx="2971800" cy="457200"/>
+          </a:xfrm>
+          <a:prstGeom prst="rect">
+            <a:avLst/>
+          </a:prstGeom>
+        </p:spPr>
+        <p:txBody>
+          <a:bodyPr vert="horz" lIns="91440" tIns="45720" rIns="91440" bIns="45720" rtlCol="0" anchor="b"/>
+          <a:lstStyle>
+            <a:lvl1pPr algn="l">
+              <a:defRPr sz="1200"/>
+            </a:lvl1pPr>
+          </a:lstStyle>
+          <a:p>
+            <a:endParaRPr lang="en-US"/>
+          </a:p>
+        </p:txBody>
+      </p:sp>
+      <p:sp>
+        <p:nvSpPr>
+          <p:cNvPr id="7" name="Slide Number Placeholder 6"/>
+          <p:cNvSpPr>
+            <a:spLocks noGrp="1"/>
+          </p:cNvSpPr>
+          <p:nvPr>
+            <p:ph type="sldNum" sz="quarter" idx="5"/>
+          </p:nvPr>
+        </p:nvSpPr>
+        <p:spPr>
+          <a:xfrm>
+            <a:off x="3884613" y="8685213"/>
+            <a:ext cx="2971800" cy="457200"/>
+          </a:xfrm>
+          <a:prstGeom prst="rect">
+            <a:avLst/>
+          </a:prstGeom>
+        </p:spPr>
+        <p:txBody>
+          <a:bodyPr vert="horz" lIns="91440" tIns="45720" rIns="91440" bIns="45720" rtlCol="0" anchor="b"/>
+          <a:lstStyle>
+            <a:lvl1pPr algn="r">
+              <a:defRPr sz="1200"/>
+            </a:lvl1pPr>
+          </a:lstStyle>
+          <a:p>
+            <a:fld id="{BB5E49A5-4136-284D-997B-48E1D791AD67}" type="slidenum">
+              <a:rPr lang="en-US" smtClean="0"/>
+              <a:t>‹#›</a:t>
+            </a:fld>
+            <a:endParaRPr lang="en-US"/>
+          </a:p>
+        </p:txBody>
+      </p:sp>
+    </p:spTree>
+    <p:extLst>
+      <p:ext uri="{BB962C8B-B14F-4D97-AF65-F5344CB8AC3E}">
+        <p14:creationId xmlns:p14="http://schemas.microsoft.com/office/powerpoint/2010/main" val="2623252185"/>
+      </p:ext>
+    </p:extLst>
+  </p:cSld>
+  <p:clrMap bg1="lt1" tx1="dk1" bg2="lt2" tx2="dk2" accent1="accent1" accent2="accent2" accent3="accent3" accent4="accent4" accent5="accent5" accent6="accent6" hlink="hlink" folHlink="folHlink"/>
+  <p:notesStyle>
+    <a:lvl1pPr marL="0" algn="l" defTabSz="457200" rtl="0" eaLnBrk="1" latinLnBrk="0" hangingPunct="1">
+      <a:defRPr sz="1200" kern="1200">
+        <a:solidFill>
+          <a:schemeClr val="tx1"/>
+        </a:solidFill>
+        <a:latin typeface="+mn-lt"/>
+        <a:ea typeface="+mn-ea"/>
+        <a:cs typeface="+mn-cs"/>
+      </a:defRPr>
+    </a:lvl1pPr>
+    <a:lvl2pPr marL="457200" algn="l" defTabSz="457200" rtl="0" eaLnBrk="1" latinLnBrk="0" hangingPunct="1">
+      <a:defRPr sz="1200" kern="1200">
+        <a:solidFill>
+          <a:schemeClr val="tx1"/>
+        </a:solidFill>
+        <a:latin typeface="+mn-lt"/>
+        <a:ea typeface="+mn-ea"/>
+        <a:cs typeface="+mn-cs"/>
+      </a:defRPr>
+    </a:lvl2pPr>
+    <a:lvl3pPr marL="914400" algn="l" defTabSz="457200" rtl="0" eaLnBrk="1" latinLnBrk="0" hangingPunct="1">
+      <a:defRPr sz="1200" kern="1200">
+        <a:solidFill>
+          <a:schemeClr val="tx1"/>
+        </a:solidFill>
+        <a:latin typeface="+mn-lt"/>
+        <a:ea typeface="+mn-ea"/>
+        <a:cs typeface="+mn-cs"/>
+      </a:defRPr>
+    </a:lvl3pPr>
+    <a:lvl4pPr marL="1371600" algn="l" defTabSz="457200" rtl="0" eaLnBrk="1" latinLnBrk="0" hangingPunct="1">
+      <a:defRPr sz="1200" kern="1200">
+        <a:solidFill>
+          <a:schemeClr val="tx1"/>
+        </a:solidFill>
+        <a:latin typeface="+mn-lt"/>
+        <a:ea typeface="+mn-ea"/>
+        <a:cs typeface="+mn-cs"/>
+      </a:defRPr>
+    </a:lvl4pPr>
+    <a:lvl5pPr marL="1828800" algn="l" defTabSz="457200" rtl="0" eaLnBrk="1" latinLnBrk="0" hangingPunct="1">
+      <a:defRPr sz="1200" kern="1200">
+        <a:solidFill>
+          <a:schemeClr val="tx1"/>
+        </a:solidFill>
+        <a:latin typeface="+mn-lt"/>
+        <a:ea typeface="+mn-ea"/>
+        <a:cs typeface="+mn-cs"/>
+      </a:defRPr>
+    </a:lvl5pPr>
+    <a:lvl6pPr marL="2286000" algn="l" defTabSz="457200" rtl="0" eaLnBrk="1" latinLnBrk="0" hangingPunct="1">
+      <a:defRPr sz="1200" kern="1200">
+        <a:solidFill>
+          <a:schemeClr val="tx1"/>
+        </a:solidFill>
+        <a:latin typeface="+mn-lt"/>
+        <a:ea typeface="+mn-ea"/>
+        <a:cs typeface="+mn-cs"/>
+      </a:defRPr>
+    </a:lvl6pPr>
+    <a:lvl7pPr marL="2743200" algn="l" defTabSz="457200" rtl="0" eaLnBrk="1" latinLnBrk="0" hangingPunct="1">
+      <a:defRPr sz="1200" kern="1200">
+        <a:solidFill>
+          <a:schemeClr val="tx1"/>
+        </a:solidFill>
+        <a:latin typeface="+mn-lt"/>
+        <a:ea typeface="+mn-ea"/>
+        <a:cs typeface="+mn-cs"/>
+      </a:defRPr>
+    </a:lvl7pPr>
+    <a:lvl8pPr marL="3200400" algn="l" defTabSz="457200" rtl="0" eaLnBrk="1" latinLnBrk="0" hangingPunct="1">
+      <a:defRPr sz="1200" kern="1200">
+        <a:solidFill>
+          <a:schemeClr val="tx1"/>
+        </a:solidFill>
+        <a:latin typeface="+mn-lt"/>
+        <a:ea typeface="+mn-ea"/>
+        <a:cs typeface="+mn-cs"/>
+      </a:defRPr>
+    </a:lvl8pPr>
+    <a:lvl9pPr marL="3657600" algn="l" defTabSz="457200" rtl="0" eaLnBrk="1" latinLnBrk="0" hangingPunct="1">
+      <a:defRPr sz="1200" kern="1200">
+        <a:solidFill>
+          <a:schemeClr val="tx1"/>
+        </a:solidFill>
+        <a:latin typeface="+mn-lt"/>
+        <a:ea typeface="+mn-ea"/>
+        <a:cs typeface="+mn-cs"/>
+      </a:defRPr>
+    </a:lvl9pPr>
+  </p:notesStyle>
+</p:notesMaster>
+</file>
+
+<file path=ppt/notesSlides/notesSlide1.xml><?xml version="1.0" encoding="utf-8"?>
+<p:notes xmlns:a="http://schemas.openxmlformats.org/drawingml/2006/main" xmlns:p="http://schemas.openxmlformats.org/presentationml/2006/main" xmlns:r="http://schemas.openxmlformats.org/officeDocument/2006/relationships">
+  <p:cSld>
+    <p:spTree>
+      <p:nvGrpSpPr>
+        <p:cNvPr id="1" name=""/>
+        <p:cNvGrpSpPr/>
+        <p:nvPr/>
+      </p:nvGrpSpPr>
+      <p:grpSpPr>
+        <a:xfrm>
+          <a:off x="0" y="0"/>
+          <a:ext cx="0" cy="0"/>
+          <a:chOff x="0" y="0"/>
+          <a:chExt cx="0" cy="0"/>
+        </a:xfrm>
+      </p:grpSpPr>
+      <p:sp>
+        <p:nvSpPr>
+          <p:cNvPr id="2" name="Slide Image Placeholder 1"/>
+          <p:cNvSpPr>
+            <a:spLocks noGrp="1"/>
+          </p:cNvSpPr>
+          <p:nvPr>
+            <p:ph type="sldImg" idx="2"/>
+          </p:nvPr>
+        </p:nvSpPr>
+        <p:spPr/>
+      </p:sp>
+      <p:sp>
+        <p:nvSpPr>
+          <p:cNvPr id="3" name="Notes Placeholder 2"/>
+          <p:cNvSpPr>
+            <a:spLocks noGrp="1"/>
+          </p:cNvSpPr>
+          <p:nvPr>
+            <p:ph type="body" idx="3" sz="quarter"/>
+          </p:nvPr>
+        </p:nvSpPr>
+        <p:spPr/>
+        <p:txBody>
+          <a:bodyPr/>
+          <a:lstStyle/>
+          <a:p>
+            <a:r>
+              <a:t>🗣️ English Speech (Say this):</a:t>
+            </a:r>
+          </a:p>
+          <a:p>
+            <a:r>
+              <a:t>Hello everyone! Today I will talk about 'Social Networks in My Life'. We use social media every day to communicate, study, and relax. Let's see how they affect our lives.</a:t>
+            </a:r>
+          </a:p>
+          <a:p/>
+          <a:p>
+            <a:r>
+              <a:t>🇺🇿 O‘zbekcha matn:</a:t>
+            </a:r>
+          </a:p>
+          <a:p>
+            <a:r>
+              <a:t>Assalomu alaykum! Bugun men 'Ijtimoiy tarmoqlar mening hayotimda' mavzusida gapirib beraman. Biz har kuni muloqot qilish, o‘qish va dam olish uchun tarmoqlardan foydalanamiz. Keling, ular hayotimizga qanday ta’sir qilishini ko‘rib chiqamiz.</a:t>
+            </a:r>
+          </a:p>
+        </p:txBody>
+      </p:sp>
+      <p:sp>
+        <p:nvSpPr>
+          <p:cNvPr id="4" name="Slide Number Placeholder 3"/>
+          <p:cNvSpPr>
+            <a:spLocks noGrp="1"/>
+          </p:cNvSpPr>
+          <p:nvPr>
+            <p:ph type="sldNum" idx="5" sz="quarter"/>
+          </p:nvPr>
+        </p:nvSpPr>
+        <p:spPr/>
+      </p:sp>
+    </p:spTree>
+  </p:cSld>
+  <p:clrMapOvr>
+    <a:masterClrMapping/>
+  </p:clrMapOvr>
+</p:notes>
+</file>
+
+<file path=ppt/notesSlides/notesSlide2.xml><?xml version="1.0" encoding="utf-8"?>
+<p:notes xmlns:a="http://schemas.openxmlformats.org/drawingml/2006/main" xmlns:p="http://schemas.openxmlformats.org/presentationml/2006/main" xmlns:r="http://schemas.openxmlformats.org/officeDocument/2006/relationships">
+  <p:cSld>
+    <p:spTree>
+      <p:nvGrpSpPr>
+        <p:cNvPr id="1" name=""/>
+        <p:cNvGrpSpPr/>
+        <p:nvPr/>
+      </p:nvGrpSpPr>
+      <p:grpSpPr>
+        <a:xfrm>
+          <a:off x="0" y="0"/>
+          <a:ext cx="0" cy="0"/>
+          <a:chOff x="0" y="0"/>
+          <a:chExt cx="0" cy="0"/>
+        </a:xfrm>
+      </p:grpSpPr>
+      <p:sp>
+        <p:nvSpPr>
+          <p:cNvPr id="2" name="Slide Image Placeholder 1"/>
+          <p:cNvSpPr>
+            <a:spLocks noGrp="1"/>
+          </p:cNvSpPr>
+          <p:nvPr>
+            <p:ph type="sldImg" idx="2"/>
+          </p:nvPr>
+        </p:nvSpPr>
+        <p:spPr/>
+      </p:sp>
+      <p:sp>
+        <p:nvSpPr>
+          <p:cNvPr id="3" name="Notes Placeholder 2"/>
+          <p:cNvSpPr>
+            <a:spLocks noGrp="1"/>
+          </p:cNvSpPr>
+          <p:nvPr>
+            <p:ph type="body" idx="3" sz="quarter"/>
+          </p:nvPr>
+        </p:nvSpPr>
+        <p:spPr/>
+        <p:txBody>
+          <a:bodyPr/>
+          <a:lstStyle/>
+          <a:p>
+            <a:r>
+              <a:t>🗣️ English Speech (Say this):</a:t>
+            </a:r>
+          </a:p>
+          <a:p>
+            <a:r>
+              <a:t>First, what are social networks? They are websites and apps where people connect, share information, and post content. Today, they are an important part of our daily life.</a:t>
+            </a:r>
+          </a:p>
+          <a:p/>
+          <a:p>
+            <a:r>
+              <a:t>🇺🇿 O‘zbekcha matn:</a:t>
+            </a:r>
+          </a:p>
+          <a:p>
+            <a:r>
+              <a:t>Avvalo, ijtimoiy tarmoqlar nima? Bu odamlar muloqot qiladigan, ma’lumot va kontent ulashadigan saytlar hamda ilovalardir. Bugun ular kundalik hayotimizning muhim qismiga aylandi.</a:t>
+            </a:r>
+          </a:p>
+        </p:txBody>
+      </p:sp>
+      <p:sp>
+        <p:nvSpPr>
+          <p:cNvPr id="4" name="Slide Number Placeholder 3"/>
+          <p:cNvSpPr>
+            <a:spLocks noGrp="1"/>
+          </p:cNvSpPr>
+          <p:nvPr>
+            <p:ph type="sldNum" idx="5" sz="quarter"/>
+          </p:nvPr>
+        </p:nvSpPr>
+        <p:spPr/>
+      </p:sp>
+    </p:spTree>
+  </p:cSld>
+  <p:clrMapOvr>
+    <a:masterClrMapping/>
+  </p:clrMapOvr>
+</p:notes>
+</file>
+
+<file path=ppt/notesSlides/notesSlide3.xml><?xml version="1.0" encoding="utf-8"?>
+<p:notes xmlns:a="http://schemas.openxmlformats.org/drawingml/2006/main" xmlns:p="http://schemas.openxmlformats.org/presentationml/2006/main" xmlns:r="http://schemas.openxmlformats.org/officeDocument/2006/relationships">
+  <p:cSld>
+    <p:spTree>
+      <p:nvGrpSpPr>
+        <p:cNvPr id="1" name=""/>
+        <p:cNvGrpSpPr/>
+        <p:nvPr/>
+      </p:nvGrpSpPr>
+      <p:grpSpPr>
+        <a:xfrm>
+          <a:off x="0" y="0"/>
+          <a:ext cx="0" cy="0"/>
+          <a:chOff x="0" y="0"/>
+          <a:chExt cx="0" cy="0"/>
+        </a:xfrm>
+      </p:grpSpPr>
+      <p:sp>
+        <p:nvSpPr>
+          <p:cNvPr id="2" name="Slide Image Placeholder 1"/>
+          <p:cNvSpPr>
+            <a:spLocks noGrp="1"/>
+          </p:cNvSpPr>
+          <p:nvPr>
+            <p:ph type="sldImg" idx="2"/>
+          </p:nvPr>
+        </p:nvSpPr>
+        <p:spPr/>
+      </p:sp>
+      <p:sp>
+        <p:nvSpPr>
+          <p:cNvPr id="3" name="Notes Placeholder 2"/>
+          <p:cNvSpPr>
+            <a:spLocks noGrp="1"/>
+          </p:cNvSpPr>
+          <p:nvPr>
+            <p:ph type="body" idx="3" sz="quarter"/>
+          </p:nvPr>
+        </p:nvSpPr>
+        <p:spPr/>
+        <p:txBody>
+          <a:bodyPr/>
+          <a:lstStyle/>
+          <a:p>
+            <a:r>
+              <a:t>🗣️ English Speech (Say this):</a:t>
+            </a:r>
+          </a:p>
+          <a:p>
+            <a:r>
+              <a:t>Here are the main apps I use: First, Telegram — for quick messaging and study groups. Second, Instagram — for photos and creative reels. And third, YouTube — for learning video tutorials and relaxing.</a:t>
+            </a:r>
+          </a:p>
+          <a:p/>
+          <a:p>
+            <a:r>
+              <a:t>🇺🇿 O‘zbekcha matn:</a:t>
+            </a:r>
+          </a:p>
+          <a:p>
+            <a:r>
+              <a:t>Men eng ko‘p foydalanadigan ilovalar: Birinchidan, Telegram — tezkor xabarlar va o‘quv guruhlari uchun. Ikkinchidan, Instagram — rasmlar va qiziqarli videolar uchun. Uchinchidan, YouTube — darslar o‘rganish va hordiq chiqarish uchun.</a:t>
+            </a:r>
+          </a:p>
+        </p:txBody>
+      </p:sp>
+      <p:sp>
+        <p:nvSpPr>
+          <p:cNvPr id="4" name="Slide Number Placeholder 3"/>
+          <p:cNvSpPr>
+            <a:spLocks noGrp="1"/>
+          </p:cNvSpPr>
+          <p:nvPr>
+            <p:ph type="sldNum" idx="5" sz="quarter"/>
+          </p:nvPr>
+        </p:nvSpPr>
+        <p:spPr/>
+      </p:sp>
+    </p:spTree>
+  </p:cSld>
+  <p:clrMapOvr>
+    <a:masterClrMapping/>
+  </p:clrMapOvr>
+</p:notes>
+</file>
+
+<file path=ppt/notesSlides/notesSlide4.xml><?xml version="1.0" encoding="utf-8"?>
+<p:notes xmlns:a="http://schemas.openxmlformats.org/drawingml/2006/main" xmlns:p="http://schemas.openxmlformats.org/presentationml/2006/main" xmlns:r="http://schemas.openxmlformats.org/officeDocument/2006/relationships">
+  <p:cSld>
+    <p:spTree>
+      <p:nvGrpSpPr>
+        <p:cNvPr id="1" name=""/>
+        <p:cNvGrpSpPr/>
+        <p:nvPr/>
+      </p:nvGrpSpPr>
+      <p:grpSpPr>
+        <a:xfrm>
+          <a:off x="0" y="0"/>
+          <a:ext cx="0" cy="0"/>
+          <a:chOff x="0" y="0"/>
+          <a:chExt cx="0" cy="0"/>
+        </a:xfrm>
+      </p:grpSpPr>
+      <p:sp>
+        <p:nvSpPr>
+          <p:cNvPr id="2" name="Slide Image Placeholder 1"/>
+          <p:cNvSpPr>
+            <a:spLocks noGrp="1"/>
+          </p:cNvSpPr>
+          <p:nvPr>
+            <p:ph type="sldImg" idx="2"/>
+          </p:nvPr>
+        </p:nvSpPr>
+        <p:spPr/>
+      </p:sp>
+      <p:sp>
+        <p:nvSpPr>
+          <p:cNvPr id="3" name="Notes Placeholder 2"/>
+          <p:cNvSpPr>
+            <a:spLocks noGrp="1"/>
+          </p:cNvSpPr>
+          <p:nvPr>
+            <p:ph type="body" idx="3" sz="quarter"/>
+          </p:nvPr>
+        </p:nvSpPr>
+        <p:spPr/>
+        <p:txBody>
+          <a:bodyPr/>
+          <a:lstStyle/>
+          <a:p>
+            <a:r>
+              <a:t>🗣️ English Speech (Say this):</a:t>
+            </a:r>
+          </a:p>
+          <a:p>
+            <a:r>
+              <a:t>Why do I use social networks? There are four main reasons: to stay in touch with friends, to read latest news, to learn new skills, and to relax after my studies.</a:t>
+            </a:r>
+          </a:p>
+          <a:p/>
+          <a:p>
+            <a:r>
+              <a:t>🇺🇿 O‘zbekcha matn:</a:t>
+            </a:r>
+          </a:p>
+          <a:p>
+            <a:r>
+              <a:t>Nega ijtimoiy tarmoqlardan foydalanaman? To‘rtta asosiy sabab bor: do‘stlar bilan aloqada bo‘lish, yangiliklarni bilish, yangi narsalarni o‘rganish va darslardan keyin dam olish.</a:t>
+            </a:r>
+          </a:p>
+        </p:txBody>
+      </p:sp>
+      <p:sp>
+        <p:nvSpPr>
+          <p:cNvPr id="4" name="Slide Number Placeholder 3"/>
+          <p:cNvSpPr>
+            <a:spLocks noGrp="1"/>
+          </p:cNvSpPr>
+          <p:nvPr>
+            <p:ph type="sldNum" idx="5" sz="quarter"/>
+          </p:nvPr>
+        </p:nvSpPr>
+        <p:spPr/>
+      </p:sp>
+    </p:spTree>
+  </p:cSld>
+  <p:clrMapOvr>
+    <a:masterClrMapping/>
+  </p:clrMapOvr>
+</p:notes>
+</file>
+
+<file path=ppt/notesSlides/notesSlide5.xml><?xml version="1.0" encoding="utf-8"?>
+<p:notes xmlns:a="http://schemas.openxmlformats.org/drawingml/2006/main" xmlns:p="http://schemas.openxmlformats.org/presentationml/2006/main" xmlns:r="http://schemas.openxmlformats.org/officeDocument/2006/relationships">
+  <p:cSld>
+    <p:spTree>
+      <p:nvGrpSpPr>
+        <p:cNvPr id="1" name=""/>
+        <p:cNvGrpSpPr/>
+        <p:nvPr/>
+      </p:nvGrpSpPr>
+      <p:grpSpPr>
+        <a:xfrm>
+          <a:off x="0" y="0"/>
+          <a:ext cx="0" cy="0"/>
+          <a:chOff x="0" y="0"/>
+          <a:chExt cx="0" cy="0"/>
+        </a:xfrm>
+      </p:grpSpPr>
+      <p:sp>
+        <p:nvSpPr>
+          <p:cNvPr id="2" name="Slide Image Placeholder 1"/>
+          <p:cNvSpPr>
+            <a:spLocks noGrp="1"/>
+          </p:cNvSpPr>
+          <p:nvPr>
+            <p:ph type="sldImg" idx="2"/>
+          </p:nvPr>
+        </p:nvSpPr>
+        <p:spPr/>
+      </p:sp>
+      <p:sp>
+        <p:nvSpPr>
+          <p:cNvPr id="3" name="Notes Placeholder 2"/>
+          <p:cNvSpPr>
+            <a:spLocks noGrp="1"/>
+          </p:cNvSpPr>
+          <p:nvPr>
+            <p:ph type="body" idx="3" sz="quarter"/>
+          </p:nvPr>
+        </p:nvSpPr>
+        <p:spPr/>
+        <p:txBody>
+          <a:bodyPr/>
+          <a:lstStyle/>
+          <a:p>
+            <a:r>
+              <a:t>🗣️ English Speech (Say this):</a:t>
+            </a:r>
+          </a:p>
+          <a:p>
+            <a:r>
+              <a:t>Let's look at communication. Social networks make talking to people very fast and easy. Even if our friends live far away, we can send messages, photos, and make video calls in seconds.</a:t>
+            </a:r>
+          </a:p>
+          <a:p/>
+          <a:p>
+            <a:r>
+              <a:t>🇺🇿 O‘zbekcha matn:</a:t>
+            </a:r>
+          </a:p>
+          <a:p>
+            <a:r>
+              <a:t>Muloqot haqida gapiradigan bo‘lsak, ijtimoiy tarmoqlar uni juda tez va oson qildi. Do‘stlarimiz uzoqda bo‘lsa ham, bir necha soniyada xabar yozishimiz, rasm yuborishimiz va video qo‘ng‘iroq qilishimiz mumkin.</a:t>
+            </a:r>
+          </a:p>
+        </p:txBody>
+      </p:sp>
+      <p:sp>
+        <p:nvSpPr>
+          <p:cNvPr id="4" name="Slide Number Placeholder 3"/>
+          <p:cNvSpPr>
+            <a:spLocks noGrp="1"/>
+          </p:cNvSpPr>
+          <p:nvPr>
+            <p:ph type="sldNum" idx="5" sz="quarter"/>
+          </p:nvPr>
+        </p:nvSpPr>
+        <p:spPr/>
+      </p:sp>
+    </p:spTree>
+  </p:cSld>
+  <p:clrMapOvr>
+    <a:masterClrMapping/>
+  </p:clrMapOvr>
+</p:notes>
+</file>
+
+<file path=ppt/notesSlides/notesSlide6.xml><?xml version="1.0" encoding="utf-8"?>
+<p:notes xmlns:a="http://schemas.openxmlformats.org/drawingml/2006/main" xmlns:p="http://schemas.openxmlformats.org/presentationml/2006/main" xmlns:r="http://schemas.openxmlformats.org/officeDocument/2006/relationships">
+  <p:cSld>
+    <p:spTree>
+      <p:nvGrpSpPr>
+        <p:cNvPr id="1" name=""/>
+        <p:cNvGrpSpPr/>
+        <p:nvPr/>
+      </p:nvGrpSpPr>
+      <p:grpSpPr>
+        <a:xfrm>
+          <a:off x="0" y="0"/>
+          <a:ext cx="0" cy="0"/>
+          <a:chOff x="0" y="0"/>
+          <a:chExt cx="0" cy="0"/>
+        </a:xfrm>
+      </p:grpSpPr>
+      <p:sp>
+        <p:nvSpPr>
+          <p:cNvPr id="2" name="Slide Image Placeholder 1"/>
+          <p:cNvSpPr>
+            <a:spLocks noGrp="1"/>
+          </p:cNvSpPr>
+          <p:nvPr>
+            <p:ph type="sldImg" idx="2"/>
+          </p:nvPr>
+        </p:nvSpPr>
+        <p:spPr/>
+      </p:sp>
+      <p:sp>
+        <p:nvSpPr>
+          <p:cNvPr id="3" name="Notes Placeholder 2"/>
+          <p:cNvSpPr>
+            <a:spLocks noGrp="1"/>
+          </p:cNvSpPr>
+          <p:nvPr>
+            <p:ph type="body" idx="3" sz="quarter"/>
+          </p:nvPr>
+        </p:nvSpPr>
+        <p:spPr/>
+        <p:txBody>
+          <a:bodyPr/>
+          <a:lstStyle/>
+          <a:p>
+            <a:r>
+              <a:t>🗣️ English Speech (Say this):</a:t>
+            </a:r>
+          </a:p>
+          <a:p>
+            <a:r>
+              <a:t>Next is education. Social networks are not just for fun — they are great for studying. We can watch free video lessons, learn English, and share study materials with classmates.</a:t>
+            </a:r>
+          </a:p>
+          <a:p/>
+          <a:p>
+            <a:r>
+              <a:t>🇺🇿 O‘zbekcha matn:</a:t>
+            </a:r>
+          </a:p>
+          <a:p>
+            <a:r>
+              <a:t>Keyingisi — ta’lim. Ijtimoiy tarmoqlar faqat o‘yin-kulgi uchun emas, balki o‘qish uchun ham juda foydali. Biz bepul video darslarni ko‘rishimiz, ingliz tilini o‘rganishimiz va kursdoshlar bilan materiallar almashishimiz mumkin.</a:t>
+            </a:r>
+          </a:p>
+        </p:txBody>
+      </p:sp>
+      <p:sp>
+        <p:nvSpPr>
+          <p:cNvPr id="4" name="Slide Number Placeholder 3"/>
+          <p:cNvSpPr>
+            <a:spLocks noGrp="1"/>
+          </p:cNvSpPr>
+          <p:nvPr>
+            <p:ph type="sldNum" idx="5" sz="quarter"/>
+          </p:nvPr>
+        </p:nvSpPr>
+        <p:spPr/>
+      </p:sp>
+    </p:spTree>
+  </p:cSld>
+  <p:clrMapOvr>
+    <a:masterClrMapping/>
+  </p:clrMapOvr>
+</p:notes>
+</file>
+
+<file path=ppt/notesSlides/notesSlide7.xml><?xml version="1.0" encoding="utf-8"?>
+<p:notes xmlns:a="http://schemas.openxmlformats.org/drawingml/2006/main" xmlns:p="http://schemas.openxmlformats.org/presentationml/2006/main" xmlns:r="http://schemas.openxmlformats.org/officeDocument/2006/relationships">
+  <p:cSld>
+    <p:spTree>
+      <p:nvGrpSpPr>
+        <p:cNvPr id="1" name=""/>
+        <p:cNvGrpSpPr/>
+        <p:nvPr/>
+      </p:nvGrpSpPr>
+      <p:grpSpPr>
+        <a:xfrm>
+          <a:off x="0" y="0"/>
+          <a:ext cx="0" cy="0"/>
+          <a:chOff x="0" y="0"/>
+          <a:chExt cx="0" cy="0"/>
+        </a:xfrm>
+      </p:grpSpPr>
+      <p:sp>
+        <p:nvSpPr>
+          <p:cNvPr id="2" name="Slide Image Placeholder 1"/>
+          <p:cNvSpPr>
+            <a:spLocks noGrp="1"/>
+          </p:cNvSpPr>
+          <p:nvPr>
+            <p:ph type="sldImg" idx="2"/>
+          </p:nvPr>
+        </p:nvSpPr>
+        <p:spPr/>
+      </p:sp>
+      <p:sp>
+        <p:nvSpPr>
+          <p:cNvPr id="3" name="Notes Placeholder 2"/>
+          <p:cNvSpPr>
+            <a:spLocks noGrp="1"/>
+          </p:cNvSpPr>
+          <p:nvPr>
+            <p:ph type="body" idx="3" sz="quarter"/>
+          </p:nvPr>
+        </p:nvSpPr>
+        <p:spPr/>
+        <p:txBody>
+          <a:bodyPr/>
+          <a:lstStyle/>
+          <a:p>
+            <a:r>
+              <a:t>🗣️ English Speech (Say this):</a:t>
+            </a:r>
+          </a:p>
+          <a:p>
+            <a:r>
+              <a:t>Now about entertainment. In our free time, we listen to music and watch interesting videos to rest. But it is important to control our screen time and not scroll for too many hours.</a:t>
+            </a:r>
+          </a:p>
+          <a:p/>
+          <a:p>
+            <a:r>
+              <a:t>🇺🇿 O‘zbekcha matn:</a:t>
+            </a:r>
+          </a:p>
+          <a:p>
+            <a:r>
+              <a:t>Endi esa dam olish haqida. Bo‘sh vaqtimizda hordiq chiqarish uchun musiqa tinglaymiz va videolar ko‘ramiz. Ammo me’yorni bilish va internetda soatlab vaqt yo‘qotmaslik muhim.</a:t>
+            </a:r>
+          </a:p>
+        </p:txBody>
+      </p:sp>
+      <p:sp>
+        <p:nvSpPr>
+          <p:cNvPr id="4" name="Slide Number Placeholder 3"/>
+          <p:cNvSpPr>
+            <a:spLocks noGrp="1"/>
+          </p:cNvSpPr>
+          <p:nvPr>
+            <p:ph type="sldNum" idx="5" sz="quarter"/>
+          </p:nvPr>
+        </p:nvSpPr>
+        <p:spPr/>
+      </p:sp>
+    </p:spTree>
+  </p:cSld>
+  <p:clrMapOvr>
+    <a:masterClrMapping/>
+  </p:clrMapOvr>
+</p:notes>
+</file>
+
+<file path=ppt/notesSlides/notesSlide8.xml><?xml version="1.0" encoding="utf-8"?>
+<p:notes xmlns:a="http://schemas.openxmlformats.org/drawingml/2006/main" xmlns:p="http://schemas.openxmlformats.org/presentationml/2006/main" xmlns:r="http://schemas.openxmlformats.org/officeDocument/2006/relationships">
+  <p:cSld>
+    <p:spTree>
+      <p:nvGrpSpPr>
+        <p:cNvPr id="1" name=""/>
+        <p:cNvGrpSpPr/>
+        <p:nvPr/>
+      </p:nvGrpSpPr>
+      <p:grpSpPr>
+        <a:xfrm>
+          <a:off x="0" y="0"/>
+          <a:ext cx="0" cy="0"/>
+          <a:chOff x="0" y="0"/>
+          <a:chExt cx="0" cy="0"/>
+        </a:xfrm>
+      </p:grpSpPr>
+      <p:sp>
+        <p:nvSpPr>
+          <p:cNvPr id="2" name="Slide Image Placeholder 1"/>
+          <p:cNvSpPr>
+            <a:spLocks noGrp="1"/>
+          </p:cNvSpPr>
+          <p:nvPr>
+            <p:ph type="sldImg" idx="2"/>
+          </p:nvPr>
+        </p:nvSpPr>
+        <p:spPr/>
+      </p:sp>
+      <p:sp>
+        <p:nvSpPr>
+          <p:cNvPr id="3" name="Notes Placeholder 2"/>
+          <p:cNvSpPr>
+            <a:spLocks noGrp="1"/>
+          </p:cNvSpPr>
+          <p:nvPr>
+            <p:ph type="body" idx="3" sz="quarter"/>
+          </p:nvPr>
+        </p:nvSpPr>
+        <p:spPr/>
+        <p:txBody>
+          <a:bodyPr/>
+          <a:lstStyle/>
+          <a:p>
+            <a:r>
+              <a:t>🗣️ English Speech (Say this):</a:t>
+            </a:r>
+          </a:p>
+          <a:p>
+            <a:r>
+              <a:t>Let's compare the pros and cons. The advantages are: easy communication, fast knowledge, and study help. The disadvantages are: losing time, getting distracted from homework, and eye tiredness.</a:t>
+            </a:r>
+          </a:p>
+          <a:p/>
+          <a:p>
+            <a:r>
+              <a:t>🇺🇿 O‘zbekcha matn:</a:t>
+            </a:r>
+          </a:p>
+          <a:p>
+            <a:r>
+              <a:t>Foyda va zararlarini solishtirsak: Foydasi — tezkor aloqa, yangi bilimlar va o‘qishdagi yordam. Zarari esa — ko‘p vaqt yo‘qotish, darslardan chalg‘ish va ko‘rish qobiliyatining toliqishi.</a:t>
+            </a:r>
+          </a:p>
+        </p:txBody>
+      </p:sp>
+      <p:sp>
+        <p:nvSpPr>
+          <p:cNvPr id="4" name="Slide Number Placeholder 3"/>
+          <p:cNvSpPr>
+            <a:spLocks noGrp="1"/>
+          </p:cNvSpPr>
+          <p:nvPr>
+            <p:ph type="sldNum" idx="5" sz="quarter"/>
+          </p:nvPr>
+        </p:nvSpPr>
+        <p:spPr/>
+      </p:sp>
+    </p:spTree>
+  </p:cSld>
+  <p:clrMapOvr>
+    <a:masterClrMapping/>
+  </p:clrMapOvr>
+</p:notes>
+</file>
+
+<file path=ppt/notesSlides/notesSlide9.xml><?xml version="1.0" encoding="utf-8"?>
+<p:notes xmlns:a="http://schemas.openxmlformats.org/drawingml/2006/main" xmlns:p="http://schemas.openxmlformats.org/presentationml/2006/main" xmlns:r="http://schemas.openxmlformats.org/officeDocument/2006/relationships">
+  <p:cSld>
+    <p:spTree>
+      <p:nvGrpSpPr>
+        <p:cNvPr id="1" name=""/>
+        <p:cNvGrpSpPr/>
+        <p:nvPr/>
+      </p:nvGrpSpPr>
+      <p:grpSpPr>
+        <a:xfrm>
+          <a:off x="0" y="0"/>
+          <a:ext cx="0" cy="0"/>
+          <a:chOff x="0" y="0"/>
+          <a:chExt cx="0" cy="0"/>
+        </a:xfrm>
+      </p:grpSpPr>
+      <p:sp>
+        <p:nvSpPr>
+          <p:cNvPr id="2" name="Slide Image Placeholder 1"/>
+          <p:cNvSpPr>
+            <a:spLocks noGrp="1"/>
+          </p:cNvSpPr>
+          <p:nvPr>
+            <p:ph type="sldImg" idx="2"/>
+          </p:nvPr>
+        </p:nvSpPr>
+        <p:spPr/>
+      </p:sp>
+      <p:sp>
+        <p:nvSpPr>
+          <p:cNvPr id="3" name="Notes Placeholder 2"/>
+          <p:cNvSpPr>
+            <a:spLocks noGrp="1"/>
+          </p:cNvSpPr>
+          <p:nvPr>
+            <p:ph type="body" idx="3" sz="quarter"/>
+          </p:nvPr>
+        </p:nvSpPr>
+        <p:spPr/>
+        <p:txBody>
+          <a:bodyPr/>
+          <a:lstStyle/>
+          <a:p>
+            <a:r>
+              <a:t>🗣️ English Speech (Say this):</a:t>
+            </a:r>
+          </a:p>
+          <a:p>
+            <a:r>
+              <a:t>To conclude: social networks are powerful tools if we use them wisely. They help us connect, learn, and relax. The key is to keep a healthy balance between our screens and real life. Thank you for your attention!</a:t>
+            </a:r>
+          </a:p>
+          <a:p/>
+          <a:p>
+            <a:r>
+              <a:t>🇺🇿 O‘zbekcha matn:</a:t>
+            </a:r>
+          </a:p>
+          <a:p>
+            <a:r>
+              <a:t>Xulosa qilib aytganda: ijtimoiy tarmoqlar to‘g‘ri foydalanilsa, katta foyda keltiradi. Ular muloqot qilish, o‘rganish va dam olishga yordam beradi. Eng asosiysi — virtual olam va real hayot o‘rtasida muvozanatni saqlashdir. E’tiboringiz uchun rahmat!</a:t>
+            </a:r>
+          </a:p>
+        </p:txBody>
+      </p:sp>
+      <p:sp>
+        <p:nvSpPr>
+          <p:cNvPr id="4" name="Slide Number Placeholder 3"/>
+          <p:cNvSpPr>
+            <a:spLocks noGrp="1"/>
+          </p:cNvSpPr>
+          <p:nvPr>
+            <p:ph type="sldNum" idx="5" sz="quarter"/>
+          </p:nvPr>
+        </p:nvSpPr>
+        <p:spPr/>
+      </p:sp>
+    </p:spTree>
+  </p:cSld>
+  <p:clrMapOvr>
+    <a:masterClrMapping/>
+  </p:clrMapOvr>
+</p:notes>
 </file>
 
 <file path=ppt/slideLayouts/slideLayout1.xml><?xml version="1.0" encoding="utf-8"?>
@@ -6984,4 +8108,324 @@
   </a:objectDefaults>
   <a:extraClrSchemeLst/>
 </a:theme>
+</file>
+
+<file path=ppt/theme/theme2.xml><?xml version="1.0" encoding="utf-8"?>
+<a:theme xmlns:a="http://schemas.openxmlformats.org/drawingml/2006/main" name="Office Theme">
+  <a:themeElements>
+    <a:clrScheme name="Office">
+      <a:dk1>
+        <a:sysClr val="windowText" lastClr="000000"/>
+      </a:dk1>
+      <a:lt1>
+        <a:sysClr val="window" lastClr="FFFFFF"/>
+      </a:lt1>
+      <a:dk2>
+        <a:srgbClr val="1F497D"/>
+      </a:dk2>
+      <a:lt2>
+        <a:srgbClr val="EEECE1"/>
+      </a:lt2>
+      <a:accent1>
+        <a:srgbClr val="4F81BD"/>
+      </a:accent1>
+      <a:accent2>
+        <a:srgbClr val="C0504D"/>
+      </a:accent2>
+      <a:accent3>
+        <a:srgbClr val="9BBB59"/>
+      </a:accent3>
+      <a:accent4>
+        <a:srgbClr val="8064A2"/>
+      </a:accent4>
+      <a:accent5>
+        <a:srgbClr val="4BACC6"/>
+      </a:accent5>
+      <a:accent6>
+        <a:srgbClr val="F79646"/>
+      </a:accent6>
+      <a:hlink>
+        <a:srgbClr val="0000FF"/>
+      </a:hlink>
+      <a:folHlink>
+        <a:srgbClr val="800080"/>
+      </a:folHlink>
+    </a:clrScheme>
+    <a:fontScheme name="Office">
+      <a:majorFont>
+        <a:latin typeface="Calibri"/>
+        <a:ea typeface=""/>
+        <a:cs typeface=""/>
+        <a:font script="Jpan" typeface="ＭＳ Ｐゴシック"/>
+        <a:font script="Hang" typeface="맑은 고딕"/>
+        <a:font script="Hans" typeface="宋体"/>
+        <a:font script="Hant" typeface="新細明體"/>
+        <a:font script="Arab" typeface="Times New Roman"/>
+        <a:font script="Hebr" typeface="Times New Roman"/>
+        <a:font script="Thai" typeface="Angsana New"/>
+        <a:font script="Ethi" typeface="Nyala"/>
+        <a:font script="Beng" typeface="Vrinda"/>
+        <a:font script="Gujr" typeface="Shruti"/>
+        <a:font script="Khmr" typeface="MoolBoran"/>
+        <a:font script="Knda" typeface="Tunga"/>
+        <a:font script="Guru" typeface="Raavi"/>
+        <a:font script="Cans" typeface="Euphemia"/>
+        <a:font script="Cher" typeface="Plantagenet Cherokee"/>
+        <a:font script="Yiii" typeface="Microsoft Yi Baiti"/>
+        <a:font script="Tibt" typeface="Microsoft Himalaya"/>
+        <a:font script="Thaa" typeface="MV Boli"/>
+        <a:font script="Deva" typeface="Mangal"/>
+        <a:font script="Telu" typeface="Gautami"/>
+        <a:font script="Taml" typeface="Latha"/>
+        <a:font script="Syrc" typeface="Estrangelo Edessa"/>
+        <a:font script="Orya" typeface="Kalinga"/>
+        <a:font script="Mlym" typeface="Kartika"/>
+        <a:font script="Laoo" typeface="DokChampa"/>
+        <a:font script="Sinh" typeface="Iskoola Pota"/>
+        <a:font script="Mong" typeface="Mongolian Baiti"/>
+        <a:font script="Viet" typeface="Times New Roman"/>
+        <a:font script="Uigh" typeface="Microsoft Uighur"/>
+        <a:font script="Geor" typeface="Sylfaen"/>
+      </a:majorFont>
+      <a:minorFont>
+        <a:latin typeface="Calibri"/>
+        <a:ea typeface=""/>
+        <a:cs typeface=""/>
+        <a:font script="Jpan" typeface="ＭＳ Ｐゴシック"/>
+        <a:font script="Hang" typeface="맑은 고딕"/>
+        <a:font script="Hans" typeface="宋体"/>
+        <a:font script="Hant" typeface="新細明體"/>
+        <a:font script="Arab" typeface="Arial"/>
+        <a:font script="Hebr" typeface="Arial"/>
+        <a:font script="Thai" typeface="Cordia New"/>
+        <a:font script="Ethi" typeface="Nyala"/>
+        <a:font script="Beng" typeface="Vrinda"/>
+        <a:font script="Gujr" typeface="Shruti"/>
+        <a:font script="Khmr" typeface="DaunPenh"/>
+        <a:font script="Knda" typeface="Tunga"/>
+        <a:font script="Guru" typeface="Raavi"/>
+        <a:font script="Cans" typeface="Euphemia"/>
+        <a:font script="Cher" typeface="Plantagenet Cherokee"/>
+        <a:font script="Yiii" typeface="Microsoft Yi Baiti"/>
+        <a:font script="Tibt" typeface="Microsoft Himalaya"/>
+        <a:font script="Thaa" typeface="MV Boli"/>
+        <a:font script="Deva" typeface="Mangal"/>
+        <a:font script="Telu" typeface="Gautami"/>
+        <a:font script="Taml" typeface="Latha"/>
+        <a:font script="Syrc" typeface="Estrangelo Edessa"/>
+        <a:font script="Orya" typeface="Kalinga"/>
+        <a:font script="Mlym" typeface="Kartika"/>
+        <a:font script="Laoo" typeface="DokChampa"/>
+        <a:font script="Sinh" typeface="Iskoola Pota"/>
+        <a:font script="Mong" typeface="Mongolian Baiti"/>
+        <a:font script="Viet" typeface="Arial"/>
+        <a:font script="Uigh" typeface="Microsoft Uighur"/>
+        <a:font script="Geor" typeface="Sylfaen"/>
+      </a:minorFont>
+    </a:fontScheme>
+    <a:fmtScheme name="Office">
+      <a:fillStyleLst>
+        <a:solidFill>
+          <a:schemeClr val="phClr"/>
+        </a:solidFill>
+        <a:gradFill rotWithShape="1">
+          <a:gsLst>
+            <a:gs pos="0">
+              <a:schemeClr val="phClr">
+                <a:tint val="50000"/>
+                <a:satMod val="300000"/>
+              </a:schemeClr>
+            </a:gs>
+            <a:gs pos="35000">
+              <a:schemeClr val="phClr">
+                <a:tint val="37000"/>
+                <a:satMod val="300000"/>
+              </a:schemeClr>
+            </a:gs>
+            <a:gs pos="100000">
+              <a:schemeClr val="phClr">
+                <a:tint val="15000"/>
+                <a:satMod val="350000"/>
+              </a:schemeClr>
+            </a:gs>
+          </a:gsLst>
+          <a:lin ang="16200000" scaled="1"/>
+        </a:gradFill>
+        <a:gradFill rotWithShape="1">
+          <a:gsLst>
+            <a:gs pos="0">
+              <a:schemeClr val="phClr">
+                <a:tint val="100000"/>
+                <a:shade val="100000"/>
+                <a:satMod val="130000"/>
+              </a:schemeClr>
+            </a:gs>
+            <a:gs pos="100000">
+              <a:schemeClr val="phClr">
+                <a:tint val="50000"/>
+                <a:shade val="100000"/>
+                <a:satMod val="350000"/>
+              </a:schemeClr>
+            </a:gs>
+          </a:gsLst>
+          <a:lin ang="16200000" scaled="0"/>
+        </a:gradFill>
+      </a:fillStyleLst>
+      <a:lnStyleLst>
+        <a:ln w="9525" cap="flat" cmpd="sng" algn="ctr">
+          <a:solidFill>
+            <a:schemeClr val="phClr">
+              <a:shade val="95000"/>
+              <a:satMod val="105000"/>
+            </a:schemeClr>
+          </a:solidFill>
+          <a:prstDash val="solid"/>
+        </a:ln>
+        <a:ln w="25400" cap="flat" cmpd="sng" algn="ctr">
+          <a:solidFill>
+            <a:schemeClr val="phClr"/>
+          </a:solidFill>
+          <a:prstDash val="solid"/>
+        </a:ln>
+        <a:ln w="38100" cap="flat" cmpd="sng" algn="ctr">
+          <a:solidFill>
+            <a:schemeClr val="phClr"/>
+          </a:solidFill>
+          <a:prstDash val="solid"/>
+        </a:ln>
+      </a:lnStyleLst>
+      <a:effectStyleLst>
+        <a:effectStyle>
+          <a:effectLst>
+            <a:outerShdw blurRad="40000" dist="20000" dir="5400000" rotWithShape="0">
+              <a:srgbClr val="000000">
+                <a:alpha val="38000"/>
+              </a:srgbClr>
+            </a:outerShdw>
+          </a:effectLst>
+        </a:effectStyle>
+        <a:effectStyle>
+          <a:effectLst>
+            <a:outerShdw blurRad="40000" dist="23000" dir="5400000" rotWithShape="0">
+              <a:srgbClr val="000000">
+                <a:alpha val="35000"/>
+              </a:srgbClr>
+            </a:outerShdw>
+          </a:effectLst>
+        </a:effectStyle>
+        <a:effectStyle>
+          <a:effectLst>
+            <a:outerShdw blurRad="40000" dist="23000" dir="5400000" rotWithShape="0">
+              <a:srgbClr val="000000">
+                <a:alpha val="35000"/>
+              </a:srgbClr>
+            </a:outerShdw>
+          </a:effectLst>
+          <a:scene3d>
+            <a:camera prst="orthographicFront">
+              <a:rot lat="0" lon="0" rev="0"/>
+            </a:camera>
+            <a:lightRig rig="threePt" dir="t">
+              <a:rot lat="0" lon="0" rev="1200000"/>
+            </a:lightRig>
+          </a:scene3d>
+          <a:sp3d>
+            <a:bevelT w="63500" h="25400"/>
+          </a:sp3d>
+        </a:effectStyle>
+      </a:effectStyleLst>
+      <a:bgFillStyleLst>
+        <a:solidFill>
+          <a:schemeClr val="phClr"/>
+        </a:solidFill>
+        <a:gradFill rotWithShape="1">
+          <a:gsLst>
+            <a:gs pos="0">
+              <a:schemeClr val="phClr">
+                <a:tint val="40000"/>
+                <a:satMod val="350000"/>
+              </a:schemeClr>
+            </a:gs>
+            <a:gs pos="40000">
+              <a:schemeClr val="phClr">
+                <a:tint val="45000"/>
+                <a:shade val="99000"/>
+                <a:satMod val="350000"/>
+              </a:schemeClr>
+            </a:gs>
+            <a:gs pos="100000">
+              <a:schemeClr val="phClr">
+                <a:shade val="20000"/>
+                <a:satMod val="255000"/>
+              </a:schemeClr>
+            </a:gs>
+          </a:gsLst>
+          <a:path path="circle">
+            <a:fillToRect l="50000" t="-80000" r="50000" b="180000"/>
+          </a:path>
+        </a:gradFill>
+        <a:gradFill rotWithShape="1">
+          <a:gsLst>
+            <a:gs pos="0">
+              <a:schemeClr val="phClr">
+                <a:tint val="80000"/>
+                <a:satMod val="300000"/>
+              </a:schemeClr>
+            </a:gs>
+            <a:gs pos="100000">
+              <a:schemeClr val="phClr">
+                <a:shade val="30000"/>
+                <a:satMod val="200000"/>
+              </a:schemeClr>
+            </a:gs>
+          </a:gsLst>
+          <a:path path="circle">
+            <a:fillToRect l="50000" t="50000" r="50000" b="50000"/>
+          </a:path>
+        </a:gradFill>
+      </a:bgFillStyleLst>
+    </a:fmtScheme>
+  </a:themeElements>
+  <a:objectDefaults>
+    <a:spDef>
+      <a:spPr/>
+      <a:bodyPr/>
+      <a:lstStyle/>
+      <a:style>
+        <a:lnRef idx="1">
+          <a:schemeClr val="accent1"/>
+        </a:lnRef>
+        <a:fillRef idx="3">
+          <a:schemeClr val="accent1"/>
+        </a:fillRef>
+        <a:effectRef idx="2">
+          <a:schemeClr val="accent1"/>
+        </a:effectRef>
+        <a:fontRef idx="minor">
+          <a:schemeClr val="lt1"/>
+        </a:fontRef>
+      </a:style>
+    </a:spDef>
+    <a:lnDef>
+      <a:spPr/>
+      <a:bodyPr/>
+      <a:lstStyle/>
+      <a:style>
+        <a:lnRef idx="2">
+          <a:schemeClr val="accent1"/>
+        </a:lnRef>
+        <a:fillRef idx="0">
+          <a:schemeClr val="accent1"/>
+        </a:fillRef>
+        <a:effectRef idx="1">
+          <a:schemeClr val="accent1"/>
+        </a:effectRef>
+        <a:fontRef idx="minor">
+          <a:schemeClr val="tx1"/>
+        </a:fontRef>
+      </a:style>
+    </a:lnDef>
+  </a:objectDefaults>
+  <a:extraClrSchemeLst/>
+</a:theme>
 </file>
</xml_diff>

<commit_message>
feat: phone remote control, animations, offline styles and content fixes
- Phone remote: remote_server.py (stdlib only) + remote.html, QR pairing with PIN;
  phone switches slides, shows speech notes/timer and runs the Fact or Myth quiz
- Presenter view window (P), animations (stagger, float, confetti, shake)
- Prebuilt Tailwind (styles.css) so the deck works without internet
- Fix Space skipping two slides, fix PDF export, single-line quiz badges
- Author on title slide, slide 8 speech matches slide, verifiable quiz facts
  with new Nataly Vershinina voice files, Uzbek grammar fixes
- Fix missing glyphs/icons in slide visuals; README matches actual slides

Co-Authored-By: Claude Opus 5.5 <noreply@anthropic.com>
</commit_message>
<xml_diff>
--- a/Social_Networks_in_My_Life.pptx
+++ b/Social_Networks_in_My_Life.pptx
@@ -515,7 +515,7 @@
           </a:p>
           <a:p>
             <a:r>
-              <a:t>Hello everyone! Today I will talk about 'Social Networks in My Life'. We use social media every day to communicate, study, and relax. Let's see how they affect our lives.</a:t>
+              <a:t>Hello everyone! My name is Abdulaziz. Today I will talk about 'Social Networks in My Life'. We use social media every day to communicate, study, and relax. Let's see how they affect our lives.</a:t>
             </a:r>
           </a:p>
           <a:p/>
@@ -526,7 +526,7 @@
           </a:p>
           <a:p>
             <a:r>
-              <a:t>Assalomu alaykum! Bugun men 'Ijtimoiy tarmoqlar mening hayotimda' mavzusida gapirib beraman. Biz har kuni muloqot qilish, o‘qish va dam olish uchun tarmoqlardan foydalanamiz. Keling, ular hayotimizga qanday ta’sir qilishini ko‘rib chiqamiz.</a:t>
+              <a:t>Assalomu alaykum! Mening ismim Abdulaziz. Bugun men 'Ijtimoiy tarmoqlar mening hayotimda' mavzusida gapirib beraman. Biz har kuni muloqot qilish, o‘qish va dam olish uchun tarmoqlardan foydalanamiz. Keling, ular hayotimizga qanday ta’sir qilishini ko‘rib chiqamiz.</a:t>
             </a:r>
           </a:p>
         </p:txBody>
@@ -1117,7 +1117,7 @@
           </a:p>
           <a:p>
             <a:r>
-              <a:t>Let's compare the pros and cons. The advantages are: easy communication, fast knowledge, and study help. The disadvantages are: losing time, getting distracted from homework, and eye tiredness.</a:t>
+              <a:t>Let's compare the pros and cons. The advantages are: easy communication, quick access to information, education, and entertainment. The disadvantages are: too much screen time, distraction, false information, and privacy problems.</a:t>
             </a:r>
           </a:p>
           <a:p/>
@@ -1128,7 +1128,7 @@
           </a:p>
           <a:p>
             <a:r>
-              <a:t>Foyda va zararlarini solishtirsak: Foydasi — tezkor aloqa, yangi bilimlar va o‘qishdagi yordam. Zarari esa — ko‘p vaqt yo‘qotish, darslardan chalg‘ish va ko‘rish qobiliyatining toliqishi.</a:t>
+              <a:t>Afzalliklari va kamchiliklarini solishtiraylik. Afzalliklari — oson muloqot, ma’lumotga tez kirish, ta’lim va ko‘ngilochar imkoniyatlar. Kamchiliklari — ekran qarshisida ortiqcha vaqt, diqqatning chalg‘ishi, noto‘g‘ri ma’lumotlar va maxfiylik muammolari.</a:t>
             </a:r>
           </a:p>
         </p:txBody>
@@ -4343,7 +4343,7 @@
               </a:defRPr>
             </a:pPr>
             <a:r>
-              <a:t>English · O‘zbekcha   •   01 / 09</a:t>
+              <a:t>Abdulaziz   •   Ma’mun University   •   2026</a:t>
             </a:r>
           </a:p>
         </p:txBody>

</xml_diff>

<commit_message>
feat(speech): title in English, then Uzbek, then the talk in Uzbek
Speech notes no longer start with a greeting or the presenter's name. Every
slide now shows the title to say in English, the title in Uzbek, and the
Uzbek talk — in the notes drawer, presenter window, phone remote, PPTX notes
and SPEECH_GUIDE.md.

Co-Authored-By: Claude Opus 5.5 <noreply@anthropic.com>
</commit_message>
<xml_diff>
--- a/Social_Networks_in_My_Life.pptx
+++ b/Social_Networks_in_My_Life.pptx
@@ -510,23 +510,28 @@
           <a:lstStyle/>
           <a:p>
             <a:r>
-              <a:t>🗣️ English Speech (Say this):</a:t>
-            </a:r>
-          </a:p>
-          <a:p>
-            <a:r>
-              <a:t>Hello everyone! My name is Abdulaziz. Today I will talk about 'Social Networks in My Life'. We use social media every day to communicate, study, and relax. Let's see how they affect our lives.</a:t>
+              <a:t>1️⃣ Sarlavha (avval inglizcha, keyin o‘zbekcha):</a:t>
+            </a:r>
+          </a:p>
+          <a:p>
+            <a:r>
+              <a:t>🇬🇧 Social Networks in My Life</a:t>
+            </a:r>
+          </a:p>
+          <a:p>
+            <a:r>
+              <a:t>🇺🇿 Ijtimoiy tarmoqlar mening hayotimda</a:t>
             </a:r>
           </a:p>
           <a:p/>
           <a:p>
             <a:r>
-              <a:t>🇺🇿 O‘zbekcha matn:</a:t>
-            </a:r>
-          </a:p>
-          <a:p>
-            <a:r>
-              <a:t>Assalomu alaykum! Mening ismim Abdulaziz. Bugun men 'Ijtimoiy tarmoqlar mening hayotimda' mavzusida gapirib beraman. Biz har kuni muloqot qilish, o‘qish va dam olish uchun tarmoqlardan foydalanamiz. Keling, ular hayotimizga qanday ta’sir qilishini ko‘rib chiqamiz.</a:t>
+              <a:t>2️⃣ Nutq (o‘zbekcha):</a:t>
+            </a:r>
+          </a:p>
+          <a:p>
+            <a:r>
+              <a:t>Bugun men shu mavzu haqida gapirib beraman. Biz har kuni ijtimoiy tarmoqlardan muloqot qilish, o‘qish va dam olish uchun foydalanamiz. Keling, ular hayotimizga qanday ta’sir qilishini ko‘rib chiqamiz.</a:t>
             </a:r>
           </a:p>
         </p:txBody>
@@ -596,23 +601,28 @@
           <a:lstStyle/>
           <a:p>
             <a:r>
-              <a:t>🗣️ English Speech (Say this):</a:t>
-            </a:r>
-          </a:p>
-          <a:p>
-            <a:r>
-              <a:t>First, what are social networks? They are websites and apps where people connect, share information, and post content. Today, they are an important part of our daily life.</a:t>
+              <a:t>1️⃣ Sarlavha (avval inglizcha, keyin o‘zbekcha):</a:t>
+            </a:r>
+          </a:p>
+          <a:p>
+            <a:r>
+              <a:t>🇬🇧 What Are Social Networks?</a:t>
+            </a:r>
+          </a:p>
+          <a:p>
+            <a:r>
+              <a:t>🇺🇿 Ijtimoiy tarmoqlar nima?</a:t>
             </a:r>
           </a:p>
           <a:p/>
           <a:p>
             <a:r>
-              <a:t>🇺🇿 O‘zbekcha matn:</a:t>
-            </a:r>
-          </a:p>
-          <a:p>
-            <a:r>
-              <a:t>Avvalo, ijtimoiy tarmoqlar nima? Bu odamlar muloqot qiladigan, ma’lumot va kontent ulashadigan saytlar hamda ilovalardir. Bugun ular kundalik hayotimizning muhim qismiga aylandi.</a:t>
+              <a:t>2️⃣ Nutq (o‘zbekcha):</a:t>
+            </a:r>
+          </a:p>
+          <a:p>
+            <a:r>
+              <a:t>Ijtimoiy tarmoqlar — odamlar muloqot qiladigan, ma’lumot va kontent ulashadigan saytlar hamda ilovalardir. Ularning uchta asosiy vazifasi bor: muloqot, ma’lumot va kontent almashish. Bugun ular kundalik hayotimizning muhim qismiga aylandi.</a:t>
             </a:r>
           </a:p>
         </p:txBody>
@@ -682,23 +692,28 @@
           <a:lstStyle/>
           <a:p>
             <a:r>
-              <a:t>🗣️ English Speech (Say this):</a:t>
-            </a:r>
-          </a:p>
-          <a:p>
-            <a:r>
-              <a:t>Here are the main apps I use: First, Telegram — for quick messaging and study groups. Second, Instagram — for photos and creative reels. And third, YouTube — for learning video tutorials and relaxing.</a:t>
+              <a:t>1️⃣ Sarlavha (avval inglizcha, keyin o‘zbekcha):</a:t>
+            </a:r>
+          </a:p>
+          <a:p>
+            <a:r>
+              <a:t>🇬🇧 Social Networks I Use</a:t>
+            </a:r>
+          </a:p>
+          <a:p>
+            <a:r>
+              <a:t>🇺🇿 Men foydalanadigan ijtimoiy tarmoqlar</a:t>
             </a:r>
           </a:p>
           <a:p/>
           <a:p>
             <a:r>
-              <a:t>🇺🇿 O‘zbekcha matn:</a:t>
-            </a:r>
-          </a:p>
-          <a:p>
-            <a:r>
-              <a:t>Men eng ko‘p foydalanadigan ilovalar: Birinchidan, Telegram — tezkor xabarlar va o‘quv guruhlari uchun. Ikkinchidan, Instagram — rasmlar va qiziqarli videolar uchun. Uchinchidan, YouTube — darslar o‘rganish va hordiq chiqarish uchun.</a:t>
+              <a:t>2️⃣ Nutq (o‘zbekcha):</a:t>
+            </a:r>
+          </a:p>
+          <a:p>
+            <a:r>
+              <a:t>Men eng ko‘p uchta ilovadan foydalanaman. Birinchisi — Telegram: tezkor xabarlar va o‘quv guruhlari uchun. Ikkinchisi — Instagram: rasmlar va qiziqarli videolar uchun. Uchinchisi — YouTube: video darslar va dam olish uchun.</a:t>
             </a:r>
           </a:p>
         </p:txBody>
@@ -768,23 +783,28 @@
           <a:lstStyle/>
           <a:p>
             <a:r>
-              <a:t>🗣️ English Speech (Say this):</a:t>
-            </a:r>
-          </a:p>
-          <a:p>
-            <a:r>
-              <a:t>Why do I use social networks? There are four main reasons: to stay in touch with friends, to read latest news, to learn new skills, and to relax after my studies.</a:t>
+              <a:t>1️⃣ Sarlavha (avval inglizcha, keyin o‘zbekcha):</a:t>
+            </a:r>
+          </a:p>
+          <a:p>
+            <a:r>
+              <a:t>🇬🇧 Why Do I Use Social Networks?</a:t>
+            </a:r>
+          </a:p>
+          <a:p>
+            <a:r>
+              <a:t>🇺🇿 Nega ijtimoiy tarmoqlardan foydalanaman?</a:t>
             </a:r>
           </a:p>
           <a:p/>
           <a:p>
             <a:r>
-              <a:t>🇺🇿 O‘zbekcha matn:</a:t>
-            </a:r>
-          </a:p>
-          <a:p>
-            <a:r>
-              <a:t>Nega ijtimoiy tarmoqlardan foydalanaman? To‘rtta asosiy sabab bor: do‘stlar bilan aloqada bo‘lish, yangiliklarni bilish, yangi narsalarni o‘rganish va darslardan keyin dam olish.</a:t>
+              <a:t>2️⃣ Nutq (o‘zbekcha):</a:t>
+            </a:r>
+          </a:p>
+          <a:p>
+            <a:r>
+              <a:t>Buning to‘rtta asosiy sababi bor: do‘stlar va oila bilan aloqada bo‘lish, yangiliklarni bilish, yangi narsalarni o‘rganish va darslardan keyin dam olish.</a:t>
             </a:r>
           </a:p>
         </p:txBody>
@@ -854,23 +874,28 @@
           <a:lstStyle/>
           <a:p>
             <a:r>
-              <a:t>🗣️ English Speech (Say this):</a:t>
-            </a:r>
-          </a:p>
-          <a:p>
-            <a:r>
-              <a:t>Let's look at communication. Social networks make talking to people very fast and easy. Even if our friends live far away, we can send messages, photos, and make video calls in seconds.</a:t>
+              <a:t>1️⃣ Sarlavha (avval inglizcha, keyin o‘zbekcha):</a:t>
+            </a:r>
+          </a:p>
+          <a:p>
+            <a:r>
+              <a:t>🇬🇧 Communication with People</a:t>
+            </a:r>
+          </a:p>
+          <a:p>
+            <a:r>
+              <a:t>🇺🇿 Odamlar bilan muloqot</a:t>
             </a:r>
           </a:p>
           <a:p/>
           <a:p>
             <a:r>
-              <a:t>🇺🇿 O‘zbekcha matn:</a:t>
-            </a:r>
-          </a:p>
-          <a:p>
-            <a:r>
-              <a:t>Muloqot haqida gapiradigan bo‘lsak, ijtimoiy tarmoqlar uni juda tez va oson qildi. Do‘stlarimiz uzoqda bo‘lsa ham, bir necha soniyada xabar yozishimiz, rasm yuborishimiz va video qo‘ng‘iroq qilishimiz mumkin.</a:t>
+              <a:t>2️⃣ Nutq (o‘zbekcha):</a:t>
+            </a:r>
+          </a:p>
+          <a:p>
+            <a:r>
+              <a:t>Ijtimoiy tarmoqlar muloqotni juda tez va oson qildi. Do‘stlarimiz uzoqda bo‘lsa ham, bir necha soniyada xabar yozishimiz, rasm yuborishimiz va video qo‘ng‘iroq qilishimiz mumkin.</a:t>
             </a:r>
           </a:p>
         </p:txBody>
@@ -940,23 +965,28 @@
           <a:lstStyle/>
           <a:p>
             <a:r>
-              <a:t>🗣️ English Speech (Say this):</a:t>
-            </a:r>
-          </a:p>
-          <a:p>
-            <a:r>
-              <a:t>Next is education. Social networks are not just for fun — they are great for studying. We can watch free video lessons, learn English, and share study materials with classmates.</a:t>
+              <a:t>1️⃣ Sarlavha (avval inglizcha, keyin o‘zbekcha):</a:t>
+            </a:r>
+          </a:p>
+          <a:p>
+            <a:r>
+              <a:t>🇬🇧 Learning and Education</a:t>
+            </a:r>
+          </a:p>
+          <a:p>
+            <a:r>
+              <a:t>🇺🇿 O‘rganish va ta’lim</a:t>
             </a:r>
           </a:p>
           <a:p/>
           <a:p>
             <a:r>
-              <a:t>🇺🇿 O‘zbekcha matn:</a:t>
-            </a:r>
-          </a:p>
-          <a:p>
-            <a:r>
-              <a:t>Keyingisi — ta’lim. Ijtimoiy tarmoqlar faqat o‘yin-kulgi uchun emas, balki o‘qish uchun ham juda foydali. Biz bepul video darslarni ko‘rishimiz, ingliz tilini o‘rganishimiz va kursdoshlar bilan materiallar almashishimiz mumkin.</a:t>
+              <a:t>2️⃣ Nutq (o‘zbekcha):</a:t>
+            </a:r>
+          </a:p>
+          <a:p>
+            <a:r>
+              <a:t>Ijtimoiy tarmoqlar faqat o‘yin-kulgi uchun emas, o‘qish uchun ham juda foydali. Biz bepul video darslarni ko‘rishimiz, onlayn kurslarda o‘qishimiz, ingliz tilini o‘rganishimiz va kursdoshlar bilan materiallar almashishimiz mumkin.</a:t>
             </a:r>
           </a:p>
         </p:txBody>
@@ -1026,23 +1056,28 @@
           <a:lstStyle/>
           <a:p>
             <a:r>
-              <a:t>🗣️ English Speech (Say this):</a:t>
-            </a:r>
-          </a:p>
-          <a:p>
-            <a:r>
-              <a:t>Now about entertainment. In our free time, we listen to music and watch interesting videos to rest. But it is important to control our screen time and not scroll for too many hours.</a:t>
+              <a:t>1️⃣ Sarlavha (avval inglizcha, keyin o‘zbekcha):</a:t>
+            </a:r>
+          </a:p>
+          <a:p>
+            <a:r>
+              <a:t>🇬🇧 Entertainment and Free Time</a:t>
+            </a:r>
+          </a:p>
+          <a:p>
+            <a:r>
+              <a:t>🇺🇿 Ko‘ngilochar va bo‘sh vaqt</a:t>
             </a:r>
           </a:p>
           <a:p/>
           <a:p>
             <a:r>
-              <a:t>🇺🇿 O‘zbekcha matn:</a:t>
-            </a:r>
-          </a:p>
-          <a:p>
-            <a:r>
-              <a:t>Endi esa dam olish haqida. Bo‘sh vaqtimizda hordiq chiqarish uchun musiqa tinglaymiz va videolar ko‘ramiz. Ammo me’yorni bilish va internetda soatlab vaqt yo‘qotmaslik muhim.</a:t>
+              <a:t>2️⃣ Nutq (o‘zbekcha):</a:t>
+            </a:r>
+          </a:p>
+          <a:p>
+            <a:r>
+              <a:t>Bo‘sh vaqtimizda hordiq chiqarish uchun musiqa tinglaymiz va qiziqarli videolar ko‘ramiz. Ammo me’yorni bilish va internetda soatlab vaqt yo‘qotmaslik muhim.</a:t>
             </a:r>
           </a:p>
         </p:txBody>
@@ -1112,23 +1147,28 @@
           <a:lstStyle/>
           <a:p>
             <a:r>
-              <a:t>🗣️ English Speech (Say this):</a:t>
-            </a:r>
-          </a:p>
-          <a:p>
-            <a:r>
-              <a:t>Let's compare the pros and cons. The advantages are: easy communication, quick access to information, education, and entertainment. The disadvantages are: too much screen time, distraction, false information, and privacy problems.</a:t>
+              <a:t>1️⃣ Sarlavha (avval inglizcha, keyin o‘zbekcha):</a:t>
+            </a:r>
+          </a:p>
+          <a:p>
+            <a:r>
+              <a:t>🇬🇧 Advantages and Disadvantages</a:t>
+            </a:r>
+          </a:p>
+          <a:p>
+            <a:r>
+              <a:t>🇺🇿 Afzalliklari va kamchiliklari</a:t>
             </a:r>
           </a:p>
           <a:p/>
           <a:p>
             <a:r>
-              <a:t>🇺🇿 O‘zbekcha matn:</a:t>
-            </a:r>
-          </a:p>
-          <a:p>
-            <a:r>
-              <a:t>Afzalliklari va kamchiliklarini solishtiraylik. Afzalliklari — oson muloqot, ma’lumotga tez kirish, ta’lim va ko‘ngilochar imkoniyatlar. Kamchiliklari — ekran qarshisida ortiqcha vaqt, diqqatning chalg‘ishi, noto‘g‘ri ma’lumotlar va maxfiylik muammolari.</a:t>
+              <a:t>2️⃣ Nutq (o‘zbekcha):</a:t>
+            </a:r>
+          </a:p>
+          <a:p>
+            <a:r>
+              <a:t>Afzalliklari — oson muloqot, ma’lumotga tez kirish, ta’lim va ko‘ngilochar imkoniyatlar. Kamchiliklari — ekran qarshisida ortiqcha vaqt, diqqatning chalg‘ishi, noto‘g‘ri ma’lumotlar va maxfiylik muammolari.</a:t>
             </a:r>
           </a:p>
         </p:txBody>
@@ -1198,23 +1238,28 @@
           <a:lstStyle/>
           <a:p>
             <a:r>
-              <a:t>🗣️ English Speech (Say this):</a:t>
-            </a:r>
-          </a:p>
-          <a:p>
-            <a:r>
-              <a:t>To conclude: social networks are powerful tools if we use them wisely. They help us connect, learn, and relax. The key is to keep a healthy balance between our screens and real life. Thank you for your attention!</a:t>
+              <a:t>1️⃣ Sarlavha (avval inglizcha, keyin o‘zbekcha):</a:t>
+            </a:r>
+          </a:p>
+          <a:p>
+            <a:r>
+              <a:t>🇬🇧 Conclusion</a:t>
+            </a:r>
+          </a:p>
+          <a:p>
+            <a:r>
+              <a:t>🇺🇿 Xulosa</a:t>
             </a:r>
           </a:p>
           <a:p/>
           <a:p>
             <a:r>
-              <a:t>🇺🇿 O‘zbekcha matn:</a:t>
-            </a:r>
-          </a:p>
-          <a:p>
-            <a:r>
-              <a:t>Xulosa qilib aytganda: ijtimoiy tarmoqlar to‘g‘ri foydalanilsa, katta foyda keltiradi. Ular muloqot qilish, o‘rganish va dam olishga yordam beradi. Eng asosiysi — virtual olam va real hayot o‘rtasida muvozanatni saqlashdir. E’tiboringiz uchun rahmat!</a:t>
+              <a:t>2️⃣ Nutq (o‘zbekcha):</a:t>
+            </a:r>
+          </a:p>
+          <a:p>
+            <a:r>
+              <a:t>Xulosa qilib aytganda, ijtimoiy tarmoqlardan oqilona foydalansak, ular juda foydali vositaga aylanadi. Ular muloqot qilish, o‘rganish va dam olishga yordam beradi. Eng asosiysi — virtual olam va real hayot o‘rtasida muvozanatni saqlash. E’tiboringiz uchun rahmat!</a:t>
             </a:r>
           </a:p>
         </p:txBody>

</xml_diff>